<commit_message>
Week 2 Micro Proj
New push of code pdf, proper cleaned data set. Last one I did not retain DateTime as a row because index was set to false, and the powerpoint
</commit_message>
<xml_diff>
--- a/ANA500_Micro-Project_JonathanEspedal.pptx
+++ b/ANA500_Micro-Project_JonathanEspedal.pptx
@@ -71,7 +71,7 @@
         <p:txBody>
           <a:bodyPr/>
           <a:p>
-            <a:fld id="{B80B8E1D-9B63-41A0-BC28-F153D6318221}" type="slidenum">
+            <a:fld id="{AE8669D4-D935-4754-8300-1D5C29B74CDC}" type="slidenum">
               <a:t>&lt;#&gt;</a:t>
             </a:fld>
           </a:p>
@@ -280,7 +280,7 @@
         <p:txBody>
           <a:bodyPr/>
           <a:p>
-            <a:fld id="{BEF8C0BB-93B7-4D7E-94E2-B9B7F5830580}" type="slidenum">
+            <a:fld id="{02CEC5A0-F4D3-4AB3-977F-174D4E435247}" type="slidenum">
               <a:t>&lt;#&gt;</a:t>
             </a:fld>
           </a:p>
@@ -575,7 +575,7 @@
         <p:txBody>
           <a:bodyPr/>
           <a:p>
-            <a:fld id="{19A853C6-958C-4CC1-A060-D4D858F56F94}" type="slidenum">
+            <a:fld id="{8404AFDC-F1CC-48C6-9418-8024CF8F7DD7}" type="slidenum">
               <a:t>&lt;#&gt;</a:t>
             </a:fld>
           </a:p>
@@ -956,7 +956,7 @@
         <p:txBody>
           <a:bodyPr/>
           <a:p>
-            <a:fld id="{E582C10E-3E8F-4397-BB09-1E1B6FB93D62}" type="slidenum">
+            <a:fld id="{54E17D1A-61DB-4409-B525-A3DB4D572FC4}" type="slidenum">
               <a:t>&lt;#&gt;</a:t>
             </a:fld>
           </a:p>
@@ -1039,7 +1039,7 @@
         <p:txBody>
           <a:bodyPr/>
           <a:p>
-            <a:fld id="{A5D2B5AA-1084-40B3-8F71-2DE4478F447D}" type="slidenum">
+            <a:fld id="{08FA9F6C-E47E-4281-A857-E00DDACBD85D}" type="slidenum">
               <a:t>&lt;#&gt;</a:t>
             </a:fld>
           </a:p>
@@ -1202,7 +1202,7 @@
         <p:txBody>
           <a:bodyPr/>
           <a:p>
-            <a:fld id="{33F4C431-BB6C-4762-9932-9836C10562A3}" type="slidenum">
+            <a:fld id="{FD72A5C8-1727-4E59-B8CA-50AED8D02381}" type="slidenum">
               <a:t>&lt;#&gt;</a:t>
             </a:fld>
           </a:p>
@@ -1368,7 +1368,7 @@
         <p:txBody>
           <a:bodyPr/>
           <a:p>
-            <a:fld id="{FF0BC9F1-9441-4424-B7C4-EA09908B6D41}" type="slidenum">
+            <a:fld id="{AC12E6FE-7880-429C-ACCC-613A58310235}" type="slidenum">
               <a:t>&lt;#&gt;</a:t>
             </a:fld>
           </a:p>
@@ -1577,7 +1577,7 @@
         <p:txBody>
           <a:bodyPr/>
           <a:p>
-            <a:fld id="{EA0EA838-8025-4418-9548-D4AA2CAAC7D3}" type="slidenum">
+            <a:fld id="{EA24A2C0-3B9B-463B-B33A-721C626556EF}" type="slidenum">
               <a:t>&lt;#&gt;</a:t>
             </a:fld>
           </a:p>
@@ -1700,7 +1700,7 @@
         <p:txBody>
           <a:bodyPr/>
           <a:p>
-            <a:fld id="{732E4934-6D06-4F76-823A-12DE565C55EE}" type="slidenum">
+            <a:fld id="{A0ABD655-C88E-4BA5-811F-93FAE7C144A8}" type="slidenum">
               <a:t>&lt;#&gt;</a:t>
             </a:fld>
           </a:p>
@@ -1821,7 +1821,7 @@
         <p:txBody>
           <a:bodyPr/>
           <a:p>
-            <a:fld id="{0E546975-7940-4260-9A1F-8FF6153B2DCE}" type="slidenum">
+            <a:fld id="{8005B95C-7EEE-423F-AF37-666025DC9478}" type="slidenum">
               <a:t>&lt;#&gt;</a:t>
             </a:fld>
           </a:p>
@@ -2073,7 +2073,7 @@
         <p:txBody>
           <a:bodyPr/>
           <a:p>
-            <a:fld id="{D9A10F68-E6E6-4817-9DD3-ED8702AD3144}" type="slidenum">
+            <a:fld id="{43F0948F-0541-4D15-8F73-D1ABB8F2ABD8}" type="slidenum">
               <a:t>&lt;#&gt;</a:t>
             </a:fld>
           </a:p>
@@ -2236,7 +2236,7 @@
         <p:txBody>
           <a:bodyPr/>
           <a:p>
-            <a:fld id="{30B271DB-3A43-4F69-ADD2-8961AAD6B456}" type="slidenum">
+            <a:fld id="{94BB7BF5-E70C-48F6-93D6-5738BFF56305}" type="slidenum">
               <a:t>&lt;#&gt;</a:t>
             </a:fld>
           </a:p>
@@ -2488,7 +2488,7 @@
         <p:txBody>
           <a:bodyPr/>
           <a:p>
-            <a:fld id="{BB981942-0BCC-4D72-9FB4-FC3F83209AE6}" type="slidenum">
+            <a:fld id="{BE73EAA0-78FE-4A45-BA45-770D4B969AEC}" type="slidenum">
               <a:t>&lt;#&gt;</a:t>
             </a:fld>
           </a:p>
@@ -2740,7 +2740,7 @@
         <p:txBody>
           <a:bodyPr/>
           <a:p>
-            <a:fld id="{8A10397A-39C2-4461-B488-21CEAC993DD3}" type="slidenum">
+            <a:fld id="{2921E4C0-4BD3-47B0-A972-F44AFCE51211}" type="slidenum">
               <a:t>&lt;#&gt;</a:t>
             </a:fld>
           </a:p>
@@ -2949,7 +2949,7 @@
         <p:txBody>
           <a:bodyPr/>
           <a:p>
-            <a:fld id="{B020583A-8ADA-49E3-AB01-800277BBB8DF}" type="slidenum">
+            <a:fld id="{6AE15C18-772D-436C-B490-171F7A15E324}" type="slidenum">
               <a:t>&lt;#&gt;</a:t>
             </a:fld>
           </a:p>
@@ -3244,7 +3244,7 @@
         <p:txBody>
           <a:bodyPr/>
           <a:p>
-            <a:fld id="{F50F4E0E-1439-453B-B1E8-6FBB07A0A31B}" type="slidenum">
+            <a:fld id="{BE89F735-389E-4B4C-AA56-083FA26C3B2D}" type="slidenum">
               <a:t>&lt;#&gt;</a:t>
             </a:fld>
           </a:p>
@@ -3625,7 +3625,7 @@
         <p:txBody>
           <a:bodyPr/>
           <a:p>
-            <a:fld id="{EB746B57-5AF7-43CE-A520-D0BAC8CD61E2}" type="slidenum">
+            <a:fld id="{36602ED5-BC95-44E0-AEFC-B87737F1A8F2}" type="slidenum">
               <a:t>&lt;#&gt;</a:t>
             </a:fld>
           </a:p>
@@ -3791,7 +3791,7 @@
         <p:txBody>
           <a:bodyPr/>
           <a:p>
-            <a:fld id="{B20F2A6F-B516-48FD-9A58-2FD10D516768}" type="slidenum">
+            <a:fld id="{3FE2AC8F-3EDF-4233-9171-BA54594E6D36}" type="slidenum">
               <a:t>&lt;#&gt;</a:t>
             </a:fld>
           </a:p>
@@ -4000,7 +4000,7 @@
         <p:txBody>
           <a:bodyPr/>
           <a:p>
-            <a:fld id="{F10E78F5-B456-45AF-8980-3CA2896C43A3}" type="slidenum">
+            <a:fld id="{7C68BCD1-2CBE-46E0-B5DF-3ADC32BE3139}" type="slidenum">
               <a:t>&lt;#&gt;</a:t>
             </a:fld>
           </a:p>
@@ -4123,7 +4123,7 @@
         <p:txBody>
           <a:bodyPr/>
           <a:p>
-            <a:fld id="{2F9FED63-883A-47F2-96DD-8F76C320DC9E}" type="slidenum">
+            <a:fld id="{711CE0D5-7259-4D0D-B382-C115E3483549}" type="slidenum">
               <a:t>&lt;#&gt;</a:t>
             </a:fld>
           </a:p>
@@ -4244,7 +4244,7 @@
         <p:txBody>
           <a:bodyPr/>
           <a:p>
-            <a:fld id="{D8F0201D-1E1D-45B8-A700-550111697F13}" type="slidenum">
+            <a:fld id="{26646311-50E4-49B7-A399-6DD41F18B230}" type="slidenum">
               <a:t>&lt;#&gt;</a:t>
             </a:fld>
           </a:p>
@@ -4496,7 +4496,7 @@
         <p:txBody>
           <a:bodyPr/>
           <a:p>
-            <a:fld id="{4F1011A4-E271-4445-926B-4892A7C71FD9}" type="slidenum">
+            <a:fld id="{73F73E1E-8E85-4F42-A760-48A1F716609B}" type="slidenum">
               <a:t>&lt;#&gt;</a:t>
             </a:fld>
           </a:p>
@@ -4748,7 +4748,7 @@
         <p:txBody>
           <a:bodyPr/>
           <a:p>
-            <a:fld id="{41D95C8A-94E5-474D-BFEB-2D6175DA285F}" type="slidenum">
+            <a:fld id="{F23629FD-63B2-4BF5-8921-8D7B67E9D486}" type="slidenum">
               <a:t>&lt;#&gt;</a:t>
             </a:fld>
           </a:p>
@@ -5000,7 +5000,7 @@
         <p:txBody>
           <a:bodyPr/>
           <a:p>
-            <a:fld id="{07892F4E-CA27-412C-9F35-9D44F44B6DD1}" type="slidenum">
+            <a:fld id="{A9A6E18D-B0F9-43A4-8494-5B87F9F086E4}" type="slidenum">
               <a:t>&lt;#&gt;</a:t>
             </a:fld>
           </a:p>
@@ -5068,8 +5068,8 @@
         </p:nvSpPr>
         <p:spPr>
           <a:xfrm>
-            <a:off x="838080" y="365040"/>
-            <a:ext cx="10514880" cy="1324800"/>
+            <a:off x="609480" y="273600"/>
+            <a:ext cx="10972080" cy="1144440"/>
           </a:xfrm>
           <a:prstGeom prst="rect">
             <a:avLst/>
@@ -5112,13 +5112,238 @@
             <a:spLocks noGrp="1"/>
           </p:cNvSpPr>
           <p:nvPr>
+            <p:ph type="body"/>
+          </p:nvPr>
+        </p:nvSpPr>
+        <p:spPr>
+          <a:xfrm>
+            <a:off x="609480" y="1604520"/>
+            <a:ext cx="10972080" cy="3976920"/>
+          </a:xfrm>
+          <a:prstGeom prst="rect">
+            <a:avLst/>
+          </a:prstGeom>
+          <a:noFill/>
+          <a:ln w="0">
+            <a:noFill/>
+          </a:ln>
+        </p:spPr>
+        <p:txBody>
+          <a:bodyPr lIns="0" rIns="0" tIns="0" bIns="0" anchor="t">
+            <a:normAutofit/>
+          </a:bodyPr>
+          <a:p>
+            <a:pPr marL="432000" indent="-324000">
+              <a:spcBef>
+                <a:spcPts val="1417"/>
+              </a:spcBef>
+              <a:buClr>
+                <a:srgbClr val="000000"/>
+              </a:buClr>
+              <a:buSzPct val="45000"/>
+              <a:buFont typeface="Wingdings" charset="2"/>
+              <a:buChar char=""/>
+            </a:pPr>
+            <a:r>
+              <a:rPr b="0" lang="en-US" sz="1800" spc="-1" strike="noStrike">
+                <a:solidFill>
+                  <a:srgbClr val="000000"/>
+                </a:solidFill>
+                <a:latin typeface="Arial"/>
+              </a:rPr>
+              <a:t>Click to edit the outline text format</a:t>
+            </a:r>
+            <a:endParaRPr b="0" lang="en-US" sz="1800" spc="-1" strike="noStrike">
+              <a:solidFill>
+                <a:srgbClr val="000000"/>
+              </a:solidFill>
+              <a:latin typeface="Arial"/>
+            </a:endParaRPr>
+          </a:p>
+          <a:p>
+            <a:pPr lvl="1" marL="864000" indent="-324000">
+              <a:spcBef>
+                <a:spcPts val="1134"/>
+              </a:spcBef>
+              <a:buClr>
+                <a:srgbClr val="000000"/>
+              </a:buClr>
+              <a:buSzPct val="75000"/>
+              <a:buFont typeface="Symbol" charset="2"/>
+              <a:buChar char=""/>
+            </a:pPr>
+            <a:r>
+              <a:rPr b="0" lang="en-US" sz="1800" spc="-1" strike="noStrike">
+                <a:solidFill>
+                  <a:srgbClr val="000000"/>
+                </a:solidFill>
+                <a:latin typeface="Arial"/>
+              </a:rPr>
+              <a:t>Second Outline Level</a:t>
+            </a:r>
+            <a:endParaRPr b="0" lang="en-US" sz="1800" spc="-1" strike="noStrike">
+              <a:solidFill>
+                <a:srgbClr val="000000"/>
+              </a:solidFill>
+              <a:latin typeface="Arial"/>
+            </a:endParaRPr>
+          </a:p>
+          <a:p>
+            <a:pPr lvl="2" marL="1296000" indent="-288000">
+              <a:spcBef>
+                <a:spcPts val="850"/>
+              </a:spcBef>
+              <a:buClr>
+                <a:srgbClr val="000000"/>
+              </a:buClr>
+              <a:buSzPct val="45000"/>
+              <a:buFont typeface="Wingdings" charset="2"/>
+              <a:buChar char=""/>
+            </a:pPr>
+            <a:r>
+              <a:rPr b="0" lang="en-US" sz="1800" spc="-1" strike="noStrike">
+                <a:solidFill>
+                  <a:srgbClr val="000000"/>
+                </a:solidFill>
+                <a:latin typeface="Arial"/>
+              </a:rPr>
+              <a:t>Third Outline Level</a:t>
+            </a:r>
+            <a:endParaRPr b="0" lang="en-US" sz="1800" spc="-1" strike="noStrike">
+              <a:solidFill>
+                <a:srgbClr val="000000"/>
+              </a:solidFill>
+              <a:latin typeface="Arial"/>
+            </a:endParaRPr>
+          </a:p>
+          <a:p>
+            <a:pPr lvl="3" marL="1728000" indent="-216000">
+              <a:spcBef>
+                <a:spcPts val="567"/>
+              </a:spcBef>
+              <a:buClr>
+                <a:srgbClr val="000000"/>
+              </a:buClr>
+              <a:buSzPct val="75000"/>
+              <a:buFont typeface="Symbol" charset="2"/>
+              <a:buChar char=""/>
+            </a:pPr>
+            <a:r>
+              <a:rPr b="0" lang="en-US" sz="1800" spc="-1" strike="noStrike">
+                <a:solidFill>
+                  <a:srgbClr val="000000"/>
+                </a:solidFill>
+                <a:latin typeface="Arial"/>
+              </a:rPr>
+              <a:t>Fourth Outline Level</a:t>
+            </a:r>
+            <a:endParaRPr b="0" lang="en-US" sz="1800" spc="-1" strike="noStrike">
+              <a:solidFill>
+                <a:srgbClr val="000000"/>
+              </a:solidFill>
+              <a:latin typeface="Arial"/>
+            </a:endParaRPr>
+          </a:p>
+          <a:p>
+            <a:pPr lvl="4" marL="2160000" indent="-216000">
+              <a:spcBef>
+                <a:spcPts val="283"/>
+              </a:spcBef>
+              <a:buClr>
+                <a:srgbClr val="000000"/>
+              </a:buClr>
+              <a:buSzPct val="45000"/>
+              <a:buFont typeface="Wingdings" charset="2"/>
+              <a:buChar char=""/>
+            </a:pPr>
+            <a:r>
+              <a:rPr b="0" lang="en-US" sz="1800" spc="-1" strike="noStrike">
+                <a:solidFill>
+                  <a:srgbClr val="000000"/>
+                </a:solidFill>
+                <a:latin typeface="Arial"/>
+              </a:rPr>
+              <a:t>Fifth Outline Level</a:t>
+            </a:r>
+            <a:endParaRPr b="0" lang="en-US" sz="1800" spc="-1" strike="noStrike">
+              <a:solidFill>
+                <a:srgbClr val="000000"/>
+              </a:solidFill>
+              <a:latin typeface="Arial"/>
+            </a:endParaRPr>
+          </a:p>
+          <a:p>
+            <a:pPr lvl="5" marL="2592000" indent="-216000">
+              <a:spcBef>
+                <a:spcPts val="283"/>
+              </a:spcBef>
+              <a:buClr>
+                <a:srgbClr val="000000"/>
+              </a:buClr>
+              <a:buSzPct val="45000"/>
+              <a:buFont typeface="Wingdings" charset="2"/>
+              <a:buChar char=""/>
+            </a:pPr>
+            <a:r>
+              <a:rPr b="0" lang="en-US" sz="1800" spc="-1" strike="noStrike">
+                <a:solidFill>
+                  <a:srgbClr val="000000"/>
+                </a:solidFill>
+                <a:latin typeface="Arial"/>
+              </a:rPr>
+              <a:t>Sixth Outline Level</a:t>
+            </a:r>
+            <a:endParaRPr b="0" lang="en-US" sz="1800" spc="-1" strike="noStrike">
+              <a:solidFill>
+                <a:srgbClr val="000000"/>
+              </a:solidFill>
+              <a:latin typeface="Arial"/>
+            </a:endParaRPr>
+          </a:p>
+          <a:p>
+            <a:pPr lvl="6" marL="3024000" indent="-216000">
+              <a:spcBef>
+                <a:spcPts val="283"/>
+              </a:spcBef>
+              <a:buClr>
+                <a:srgbClr val="000000"/>
+              </a:buClr>
+              <a:buSzPct val="45000"/>
+              <a:buFont typeface="Wingdings" charset="2"/>
+              <a:buChar char=""/>
+            </a:pPr>
+            <a:r>
+              <a:rPr b="0" lang="en-US" sz="1800" spc="-1" strike="noStrike">
+                <a:solidFill>
+                  <a:srgbClr val="000000"/>
+                </a:solidFill>
+                <a:latin typeface="Arial"/>
+              </a:rPr>
+              <a:t>Seventh Outline Level</a:t>
+            </a:r>
+            <a:endParaRPr b="0" lang="en-US" sz="1800" spc="-1" strike="noStrike">
+              <a:solidFill>
+                <a:srgbClr val="000000"/>
+              </a:solidFill>
+              <a:latin typeface="Arial"/>
+            </a:endParaRPr>
+          </a:p>
+        </p:txBody>
+      </p:sp>
+      <p:sp>
+        <p:nvSpPr>
+          <p:cNvPr id="2" name="PlaceHolder 3"/>
+          <p:cNvSpPr>
+            <a:spLocks noGrp="1"/>
+          </p:cNvSpPr>
+          <p:nvPr>
             <p:ph type="ftr" idx="1"/>
           </p:nvPr>
         </p:nvSpPr>
         <p:spPr>
           <a:xfrm>
             <a:off x="4038480" y="6356520"/>
-            <a:ext cx="4114080" cy="364320"/>
+            <a:ext cx="4113720" cy="363960"/>
           </a:xfrm>
           <a:prstGeom prst="rect">
             <a:avLst/>
@@ -5166,7 +5391,7 @@
                 </a:solidFill>
                 <a:latin typeface="Times New Roman"/>
               </a:rPr>
-              <a:t> </a:t>
+              <a:t>&lt;footer&gt;</a:t>
             </a:r>
             <a:endParaRPr b="0" lang="en-US" sz="1400" spc="-1" strike="noStrike">
               <a:solidFill>
@@ -5179,7 +5404,7 @@
       </p:sp>
       <p:sp>
         <p:nvSpPr>
-          <p:cNvPr id="2" name="PlaceHolder 3"/>
+          <p:cNvPr id="3" name="PlaceHolder 4"/>
           <p:cNvSpPr>
             <a:spLocks noGrp="1"/>
           </p:cNvSpPr>
@@ -5190,7 +5415,7 @@
         <p:spPr>
           <a:xfrm>
             <a:off x="8610480" y="6356520"/>
-            <a:ext cx="2742480" cy="364320"/>
+            <a:ext cx="2742120" cy="363960"/>
           </a:xfrm>
           <a:prstGeom prst="rect">
             <a:avLst/>
@@ -5231,14 +5456,14 @@
                 <a:tab algn="l" pos="0"/>
               </a:tabLst>
             </a:pPr>
-            <a:fld id="{28F16173-0AC0-4814-8B69-528E8CE4E4C0}" type="slidenum">
+            <a:fld id="{41ED8EA6-A494-417D-9E5E-FA1A91518DDA}" type="slidenum">
               <a:rPr b="0" lang="en-US" sz="1200" spc="-1" strike="noStrike">
                 <a:solidFill>
                   <a:srgbClr val="8b8b8b"/>
                 </a:solidFill>
                 <a:latin typeface="Calibri"/>
               </a:rPr>
-              <a:t>1</a:t>
+              <a:t>&lt;number&gt;</a:t>
             </a:fld>
             <a:endParaRPr b="0" lang="en-US" sz="1200" spc="-1" strike="noStrike">
               <a:solidFill>
@@ -5251,7 +5476,7 @@
       </p:sp>
       <p:sp>
         <p:nvSpPr>
-          <p:cNvPr id="3" name="PlaceHolder 4"/>
+          <p:cNvPr id="4" name="PlaceHolder 5"/>
           <p:cNvSpPr>
             <a:spLocks noGrp="1"/>
           </p:cNvSpPr>
@@ -5262,7 +5487,7 @@
         <p:spPr>
           <a:xfrm>
             <a:off x="838080" y="6356520"/>
-            <a:ext cx="2742480" cy="364320"/>
+            <a:ext cx="2742120" cy="363960"/>
           </a:xfrm>
           <a:prstGeom prst="rect">
             <a:avLst/>
@@ -5298,238 +5523,13 @@
                 </a:solidFill>
                 <a:latin typeface="Times New Roman"/>
               </a:rPr>
-              <a:t> </a:t>
+              <a:t>&lt;date/time&gt;</a:t>
             </a:r>
             <a:endParaRPr b="0" lang="en-US" sz="1400" spc="-1" strike="noStrike">
               <a:solidFill>
                 <a:srgbClr val="000000"/>
               </a:solidFill>
               <a:latin typeface="Times New Roman"/>
-            </a:endParaRPr>
-          </a:p>
-        </p:txBody>
-      </p:sp>
-      <p:sp>
-        <p:nvSpPr>
-          <p:cNvPr id="4" name="PlaceHolder 5"/>
-          <p:cNvSpPr>
-            <a:spLocks noGrp="1"/>
-          </p:cNvSpPr>
-          <p:nvPr>
-            <p:ph type="body"/>
-          </p:nvPr>
-        </p:nvSpPr>
-        <p:spPr>
-          <a:xfrm>
-            <a:off x="609480" y="1604520"/>
-            <a:ext cx="10972440" cy="3977280"/>
-          </a:xfrm>
-          <a:prstGeom prst="rect">
-            <a:avLst/>
-          </a:prstGeom>
-          <a:noFill/>
-          <a:ln w="0">
-            <a:noFill/>
-          </a:ln>
-        </p:spPr>
-        <p:txBody>
-          <a:bodyPr lIns="0" rIns="0" tIns="0" bIns="0" anchor="t">
-            <a:normAutofit/>
-          </a:bodyPr>
-          <a:p>
-            <a:pPr marL="432000" indent="-324000">
-              <a:spcBef>
-                <a:spcPts val="1417"/>
-              </a:spcBef>
-              <a:buClr>
-                <a:srgbClr val="000000"/>
-              </a:buClr>
-              <a:buSzPct val="45000"/>
-              <a:buFont typeface="Wingdings" charset="2"/>
-              <a:buChar char=""/>
-            </a:pPr>
-            <a:r>
-              <a:rPr b="0" lang="en-US" sz="3200" spc="-1" strike="noStrike">
-                <a:solidFill>
-                  <a:srgbClr val="000000"/>
-                </a:solidFill>
-                <a:latin typeface="Arial"/>
-              </a:rPr>
-              <a:t>Click to edit the outline text format</a:t>
-            </a:r>
-            <a:endParaRPr b="0" lang="en-US" sz="3200" spc="-1" strike="noStrike">
-              <a:solidFill>
-                <a:srgbClr val="000000"/>
-              </a:solidFill>
-              <a:latin typeface="Arial"/>
-            </a:endParaRPr>
-          </a:p>
-          <a:p>
-            <a:pPr lvl="1" marL="864000" indent="-324000">
-              <a:spcBef>
-                <a:spcPts val="1134"/>
-              </a:spcBef>
-              <a:buClr>
-                <a:srgbClr val="000000"/>
-              </a:buClr>
-              <a:buSzPct val="75000"/>
-              <a:buFont typeface="Symbol" charset="2"/>
-              <a:buChar char=""/>
-            </a:pPr>
-            <a:r>
-              <a:rPr b="0" lang="en-US" sz="2800" spc="-1" strike="noStrike">
-                <a:solidFill>
-                  <a:srgbClr val="000000"/>
-                </a:solidFill>
-                <a:latin typeface="Arial"/>
-              </a:rPr>
-              <a:t>Second Outline Level</a:t>
-            </a:r>
-            <a:endParaRPr b="0" lang="en-US" sz="2800" spc="-1" strike="noStrike">
-              <a:solidFill>
-                <a:srgbClr val="000000"/>
-              </a:solidFill>
-              <a:latin typeface="Arial"/>
-            </a:endParaRPr>
-          </a:p>
-          <a:p>
-            <a:pPr lvl="2" marL="1296000" indent="-288000">
-              <a:spcBef>
-                <a:spcPts val="850"/>
-              </a:spcBef>
-              <a:buClr>
-                <a:srgbClr val="000000"/>
-              </a:buClr>
-              <a:buSzPct val="45000"/>
-              <a:buFont typeface="Wingdings" charset="2"/>
-              <a:buChar char=""/>
-            </a:pPr>
-            <a:r>
-              <a:rPr b="0" lang="en-US" sz="2400" spc="-1" strike="noStrike">
-                <a:solidFill>
-                  <a:srgbClr val="000000"/>
-                </a:solidFill>
-                <a:latin typeface="Arial"/>
-              </a:rPr>
-              <a:t>Third Outline Level</a:t>
-            </a:r>
-            <a:endParaRPr b="0" lang="en-US" sz="2400" spc="-1" strike="noStrike">
-              <a:solidFill>
-                <a:srgbClr val="000000"/>
-              </a:solidFill>
-              <a:latin typeface="Arial"/>
-            </a:endParaRPr>
-          </a:p>
-          <a:p>
-            <a:pPr lvl="3" marL="1728000" indent="-216000">
-              <a:spcBef>
-                <a:spcPts val="567"/>
-              </a:spcBef>
-              <a:buClr>
-                <a:srgbClr val="000000"/>
-              </a:buClr>
-              <a:buSzPct val="75000"/>
-              <a:buFont typeface="Symbol" charset="2"/>
-              <a:buChar char=""/>
-            </a:pPr>
-            <a:r>
-              <a:rPr b="0" lang="en-US" sz="2000" spc="-1" strike="noStrike">
-                <a:solidFill>
-                  <a:srgbClr val="000000"/>
-                </a:solidFill>
-                <a:latin typeface="Arial"/>
-              </a:rPr>
-              <a:t>Fourth Outline Level</a:t>
-            </a:r>
-            <a:endParaRPr b="0" lang="en-US" sz="2000" spc="-1" strike="noStrike">
-              <a:solidFill>
-                <a:srgbClr val="000000"/>
-              </a:solidFill>
-              <a:latin typeface="Arial"/>
-            </a:endParaRPr>
-          </a:p>
-          <a:p>
-            <a:pPr lvl="4" marL="2160000" indent="-216000">
-              <a:spcBef>
-                <a:spcPts val="283"/>
-              </a:spcBef>
-              <a:buClr>
-                <a:srgbClr val="000000"/>
-              </a:buClr>
-              <a:buSzPct val="45000"/>
-              <a:buFont typeface="Wingdings" charset="2"/>
-              <a:buChar char=""/>
-            </a:pPr>
-            <a:r>
-              <a:rPr b="0" lang="en-US" sz="2000" spc="-1" strike="noStrike">
-                <a:solidFill>
-                  <a:srgbClr val="000000"/>
-                </a:solidFill>
-                <a:latin typeface="Arial"/>
-              </a:rPr>
-              <a:t>Fifth Outline Level</a:t>
-            </a:r>
-            <a:endParaRPr b="0" lang="en-US" sz="2000" spc="-1" strike="noStrike">
-              <a:solidFill>
-                <a:srgbClr val="000000"/>
-              </a:solidFill>
-              <a:latin typeface="Arial"/>
-            </a:endParaRPr>
-          </a:p>
-          <a:p>
-            <a:pPr lvl="5" marL="2592000" indent="-216000">
-              <a:spcBef>
-                <a:spcPts val="283"/>
-              </a:spcBef>
-              <a:buClr>
-                <a:srgbClr val="000000"/>
-              </a:buClr>
-              <a:buSzPct val="45000"/>
-              <a:buFont typeface="Wingdings" charset="2"/>
-              <a:buChar char=""/>
-            </a:pPr>
-            <a:r>
-              <a:rPr b="0" lang="en-US" sz="2000" spc="-1" strike="noStrike">
-                <a:solidFill>
-                  <a:srgbClr val="000000"/>
-                </a:solidFill>
-                <a:latin typeface="Arial"/>
-              </a:rPr>
-              <a:t>Sixth Outline Level</a:t>
-            </a:r>
-            <a:endParaRPr b="0" lang="en-US" sz="2000" spc="-1" strike="noStrike">
-              <a:solidFill>
-                <a:srgbClr val="000000"/>
-              </a:solidFill>
-              <a:latin typeface="Arial"/>
-            </a:endParaRPr>
-          </a:p>
-          <a:p>
-            <a:pPr lvl="6" marL="3024000" indent="-216000">
-              <a:spcBef>
-                <a:spcPts val="283"/>
-              </a:spcBef>
-              <a:buClr>
-                <a:srgbClr val="000000"/>
-              </a:buClr>
-              <a:buSzPct val="45000"/>
-              <a:buFont typeface="Wingdings" charset="2"/>
-              <a:buChar char=""/>
-            </a:pPr>
-            <a:r>
-              <a:rPr b="0" lang="en-US" sz="2000" spc="-1" strike="noStrike">
-                <a:solidFill>
-                  <a:srgbClr val="000000"/>
-                </a:solidFill>
-                <a:latin typeface="Arial"/>
-              </a:rPr>
-              <a:t>Seventh Outline Level</a:t>
-            </a:r>
-            <a:endParaRPr b="0" lang="en-US" sz="2000" spc="-1" strike="noStrike">
-              <a:solidFill>
-                <a:srgbClr val="000000"/>
-              </a:solidFill>
-              <a:latin typeface="Arial"/>
             </a:endParaRPr>
           </a:p>
         </p:txBody>
@@ -5591,7 +5591,7 @@
         <p:spPr>
           <a:xfrm>
             <a:off x="4038480" y="6356520"/>
-            <a:ext cx="4114080" cy="364320"/>
+            <a:ext cx="4113720" cy="363960"/>
           </a:xfrm>
           <a:prstGeom prst="rect">
             <a:avLst/>
@@ -5663,7 +5663,7 @@
         <p:spPr>
           <a:xfrm>
             <a:off x="8610480" y="6356520"/>
-            <a:ext cx="2742480" cy="364320"/>
+            <a:ext cx="2742120" cy="363960"/>
           </a:xfrm>
           <a:prstGeom prst="rect">
             <a:avLst/>
@@ -5704,7 +5704,7 @@
                 <a:tab algn="l" pos="0"/>
               </a:tabLst>
             </a:pPr>
-            <a:fld id="{DBE8C7D0-1E27-40DB-BBD0-14EC65A858B0}" type="slidenum">
+            <a:fld id="{B86050BC-6EE3-426B-84BB-87FA6F0ACC0F}" type="slidenum">
               <a:rPr b="0" lang="en-US" sz="1200" spc="-1" strike="noStrike">
                 <a:solidFill>
                   <a:srgbClr val="8b8b8b"/>
@@ -5735,7 +5735,7 @@
         <p:spPr>
           <a:xfrm>
             <a:off x="838080" y="6356520"/>
-            <a:ext cx="2742480" cy="364320"/>
+            <a:ext cx="2742120" cy="363960"/>
           </a:xfrm>
           <a:prstGeom prst="rect">
             <a:avLst/>
@@ -6106,7 +6106,7 @@
         <p:spPr>
           <a:xfrm>
             <a:off x="1523880" y="1122480"/>
-            <a:ext cx="9143280" cy="2386800"/>
+            <a:ext cx="9142920" cy="2386440"/>
           </a:xfrm>
           <a:prstGeom prst="rect">
             <a:avLst/>
@@ -6155,10 +6155,11 @@
               <a:rPr sz="4800"/>
             </a:br>
             <a:r>
-              <a:rPr b="0" lang="en-US" sz="4800" spc="-1" strike="noStrike">
+              <a:rPr b="0" lang="en-US" sz="4800" spc="-1" strike="noStrike" u="sng">
                 <a:solidFill>
-                  <a:srgbClr val="000000"/>
+                  <a:srgbClr val="0563c1"/>
                 </a:solidFill>
+                <a:uFillTx/>
                 <a:latin typeface="Calibri Light"/>
                 <a:hlinkClick r:id="rId1"/>
               </a:rPr>
@@ -6186,7 +6187,7 @@
         <p:spPr>
           <a:xfrm>
             <a:off x="1523880" y="3602160"/>
-            <a:ext cx="9143280" cy="1654920"/>
+            <a:ext cx="9142920" cy="1654560"/>
           </a:xfrm>
           <a:prstGeom prst="rect">
             <a:avLst/>
@@ -6249,7 +6250,7 @@
                 </a:solidFill>
                 <a:latin typeface="Calibri"/>
               </a:rPr>
-              <a:t>20 SEP 2026</a:t>
+              <a:t>25 SEP 2026</a:t>
             </a:r>
             <a:endParaRPr b="0" lang="en-US" sz="2400" spc="-1" strike="noStrike">
               <a:solidFill>
@@ -6323,7 +6324,7 @@
         <p:spPr>
           <a:xfrm>
             <a:off x="838080" y="365040"/>
-            <a:ext cx="10514880" cy="1324800"/>
+            <a:ext cx="10514520" cy="1324440"/>
           </a:xfrm>
           <a:prstGeom prst="rect">
             <a:avLst/>
@@ -6378,7 +6379,7 @@
         <p:spPr>
           <a:xfrm>
             <a:off x="838080" y="1825560"/>
-            <a:ext cx="10514880" cy="4350600"/>
+            <a:ext cx="10514520" cy="4350240"/>
           </a:xfrm>
           <a:prstGeom prst="rect">
             <a:avLst/>
@@ -6401,6 +6402,9 @@
                 <a:spcPts val="1001"/>
               </a:spcBef>
               <a:buNone/>
+              <a:tabLst>
+                <a:tab algn="l" pos="0"/>
+              </a:tabLst>
             </a:pPr>
             <a:r>
               <a:rPr b="0" lang="en-US" sz="1800" spc="-1" strike="noStrike">
@@ -6410,7 +6414,7 @@
                 <a:latin typeface="Times New Roman"/>
                 <a:ea typeface="Times New Roman"/>
               </a:rPr>
-              <a:t>Understanding how and when peak electricity demand occurs across different Moroccan regions is important for infrastructure planning, but existing analyses rarely compare high-resolution, city-level consumption data side by side.</a:t>
+              <a:t>This project analyzes high-resolution smart meter data from four Moroccan cities (Laâyoune, Boujdour, Foum Eloued, and Marrakech) to classify electricity load readings as peak-demand or normal-demand periods. Because Laâyoune, Boujdour, and Foum Eloued are metered in Amperes while Marrakech is metered in Kilowatts, load values will be converted to a common unit using a standard voltage assumption before peak-demand magnitude is compared across cities. The goal is to identify when, how often, and how intensely peak-demand periods occur in each region, to inform infrastructure and demand-response planning.</a:t>
             </a:r>
             <a:endParaRPr b="0" lang="en-US" sz="1800" spc="-1" strike="noStrike">
               <a:solidFill>
@@ -6464,7 +6468,7 @@
         <p:spPr>
           <a:xfrm>
             <a:off x="838080" y="365040"/>
-            <a:ext cx="10514880" cy="1324800"/>
+            <a:ext cx="10514520" cy="1324440"/>
           </a:xfrm>
           <a:prstGeom prst="rect">
             <a:avLst/>
@@ -6519,7 +6523,7 @@
         <p:spPr>
           <a:xfrm>
             <a:off x="838080" y="1825560"/>
-            <a:ext cx="10514880" cy="4350600"/>
+            <a:ext cx="10514520" cy="4350240"/>
           </a:xfrm>
           <a:prstGeom prst="rect">
             <a:avLst/>
@@ -6542,6 +6546,9 @@
                 <a:spcPts val="1001"/>
               </a:spcBef>
               <a:buNone/>
+              <a:tabLst>
+                <a:tab algn="l" pos="0"/>
+              </a:tabLst>
             </a:pPr>
             <a:r>
               <a:rPr b="0" lang="en-US" sz="1800" spc="-1" strike="noStrike">
@@ -6551,7 +6558,7 @@
                 <a:latin typeface="Times New Roman"/>
                 <a:ea typeface="Times New Roman"/>
               </a:rPr>
-              <a:t>Peak load timing and intensity will vary significantly between cities/zones (e.g., Marrakech vs. the Laâyoune-area cities), and this variation will correlate with time-of-year, suggesting different infrastructure or policy responses may be needed by region.</a:t>
+              <a:t>After converting all readings to a common unit (kW) and defining peak demand as load exceeding the 90th percentile of each city's own distribution, the timing, frequency, and relative intensity of peak-demand periods will differ significantly across cities/zones, and these differences will correlate with season and zone type (domestic vs. industrial) rather than occurring uniformly across regions.</a:t>
             </a:r>
             <a:endParaRPr b="0" lang="en-US" sz="1800" spc="-1" strike="noStrike">
               <a:solidFill>
@@ -6605,7 +6612,7 @@
         <p:spPr>
           <a:xfrm>
             <a:off x="838080" y="365040"/>
-            <a:ext cx="10514880" cy="1324800"/>
+            <a:ext cx="10514520" cy="1324440"/>
           </a:xfrm>
           <a:prstGeom prst="rect">
             <a:avLst/>
@@ -6660,7 +6667,7 @@
         <p:spPr>
           <a:xfrm>
             <a:off x="838080" y="1825560"/>
-            <a:ext cx="10514880" cy="4350600"/>
+            <a:ext cx="10514520" cy="4350240"/>
           </a:xfrm>
           <a:prstGeom prst="rect">
             <a:avLst/>
@@ -6683,6 +6690,9 @@
                 <a:spcPts val="1001"/>
               </a:spcBef>
               <a:buNone/>
+              <a:tabLst>
+                <a:tab algn="l" pos="0"/>
+              </a:tabLst>
             </a:pPr>
             <a:r>
               <a:rPr b="0" lang="en-US" sz="1800" spc="-1" strike="noStrike">
@@ -6710,6 +6720,9 @@
                 <a:spcPts val="1001"/>
               </a:spcBef>
               <a:buNone/>
+              <a:tabLst>
+                <a:tab algn="l" pos="0"/>
+              </a:tabLst>
             </a:pPr>
             <a:endParaRPr b="0" lang="en-US" sz="1800" spc="-1" strike="noStrike">
               <a:solidFill>
@@ -6727,6 +6740,9 @@
                 <a:spcPts val="1001"/>
               </a:spcBef>
               <a:buNone/>
+              <a:tabLst>
+                <a:tab algn="l" pos="0"/>
+              </a:tabLst>
             </a:pPr>
             <a:endParaRPr b="0" lang="en-US" sz="1800" spc="-1" strike="noStrike">
               <a:solidFill>
@@ -6744,6 +6760,9 @@
                 <a:spcPts val="1001"/>
               </a:spcBef>
               <a:buNone/>
+              <a:tabLst>
+                <a:tab algn="l" pos="0"/>
+              </a:tabLst>
             </a:pPr>
             <a:r>
               <a:rPr b="0" lang="en-US" sz="1800" spc="-1" strike="noStrike">
@@ -6763,7 +6782,7 @@
             </a:endParaRPr>
           </a:p>
           <a:p>
-            <a:pPr indent="0">
+            <a:pPr marL="228600" indent="0">
               <a:lnSpc>
                 <a:spcPct val="90000"/>
               </a:lnSpc>
@@ -6771,6 +6790,9 @@
                 <a:spcPts val="1001"/>
               </a:spcBef>
               <a:buNone/>
+              <a:tabLst>
+                <a:tab algn="l" pos="0"/>
+              </a:tabLst>
             </a:pPr>
             <a:r>
               <a:rPr b="0" lang="en-US" sz="1800" spc="-1" strike="noStrike">
@@ -6790,7 +6812,7 @@
             </a:endParaRPr>
           </a:p>
           <a:p>
-            <a:pPr indent="0">
+            <a:pPr marL="228600" indent="0">
               <a:lnSpc>
                 <a:spcPct val="90000"/>
               </a:lnSpc>
@@ -6853,8 +6875,8 @@
         </p:nvSpPr>
         <p:spPr>
           <a:xfrm>
-            <a:off x="838080" y="365040"/>
-            <a:ext cx="10514880" cy="1324800"/>
+            <a:off x="1080" y="0"/>
+            <a:ext cx="7999920" cy="914400"/>
           </a:xfrm>
           <a:prstGeom prst="rect">
             <a:avLst/>
@@ -6908,8 +6930,8 @@
         </p:nvSpPr>
         <p:spPr>
           <a:xfrm>
-            <a:off x="838080" y="1825560"/>
-            <a:ext cx="10514880" cy="4350600"/>
+            <a:off x="0" y="651600"/>
+            <a:ext cx="12115800" cy="6206400"/>
           </a:xfrm>
           <a:prstGeom prst="rect">
             <a:avLst/>
@@ -6924,18 +6946,14 @@
             <a:noAutofit/>
           </a:bodyPr>
           <a:p>
-            <a:pPr marL="228600" indent="-228600">
+            <a:pPr marL="228600" indent="0">
               <a:lnSpc>
                 <a:spcPct val="90000"/>
               </a:lnSpc>
               <a:spcBef>
                 <a:spcPts val="1001"/>
               </a:spcBef>
-              <a:buClr>
-                <a:srgbClr val="000000"/>
-              </a:buClr>
-              <a:buFont typeface="Arial"/>
-              <a:buChar char="•"/>
+              <a:buNone/>
             </a:pPr>
             <a:r>
               <a:rPr b="0" lang="en-US" sz="1800" spc="-1" strike="noStrike">
@@ -6955,18 +6973,14 @@
             </a:endParaRPr>
           </a:p>
           <a:p>
-            <a:pPr marL="228600" indent="-228600">
+            <a:pPr marL="228600" indent="0">
               <a:lnSpc>
                 <a:spcPct val="90000"/>
               </a:lnSpc>
               <a:spcBef>
                 <a:spcPts val="1001"/>
               </a:spcBef>
-              <a:buClr>
-                <a:srgbClr val="000000"/>
-              </a:buClr>
-              <a:buFont typeface="Arial"/>
-              <a:buChar char="•"/>
+              <a:buNone/>
             </a:pPr>
             <a:r>
               <a:rPr b="0" lang="en-US" sz="1800" spc="-1" strike="noStrike">
@@ -6986,18 +7000,14 @@
             </a:endParaRPr>
           </a:p>
           <a:p>
-            <a:pPr marL="228600" indent="-228600">
+            <a:pPr marL="228600" indent="0">
               <a:lnSpc>
                 <a:spcPct val="90000"/>
               </a:lnSpc>
               <a:spcBef>
                 <a:spcPts val="1001"/>
               </a:spcBef>
-              <a:buClr>
-                <a:srgbClr val="000000"/>
-              </a:buClr>
-              <a:buFont typeface="Symbol" charset="2"/>
-              <a:buChar char=""/>
+              <a:buNone/>
             </a:pPr>
             <a:r>
               <a:rPr b="0" lang="en-US" sz="1800" spc="-1" strike="noStrike">
@@ -7007,8 +7017,25 @@
                 <a:latin typeface="Times New Roman"/>
                 <a:ea typeface="Times New Roman"/>
               </a:rPr>
-              <a:t>Identified a units mismatch: </a:t>
-            </a:r>
+              <a:t>Identified a units mismatch: Laâyoune, Boujdour, and Foum Eloued are recorded in Amperes, while Marrakech is recorded in Kilowatts. This will be a known limitation for a direct cross-city magnitude comparison unless we do a unit conversion per row.</a:t>
+            </a:r>
+            <a:endParaRPr b="0" lang="en-US" sz="1800" spc="-1" strike="noStrike">
+              <a:solidFill>
+                <a:srgbClr val="000000"/>
+              </a:solidFill>
+              <a:latin typeface="Arial"/>
+            </a:endParaRPr>
+          </a:p>
+          <a:p>
+            <a:pPr indent="0">
+              <a:lnSpc>
+                <a:spcPct val="90000"/>
+              </a:lnSpc>
+              <a:spcBef>
+                <a:spcPts val="1001"/>
+              </a:spcBef>
+              <a:buNone/>
+            </a:pPr>
             <a:r>
               <a:rPr b="0" lang="en-US" sz="1800" spc="-1" strike="noStrike">
                 <a:solidFill>
@@ -7017,7 +7044,7 @@
                 <a:latin typeface="Times New Roman"/>
                 <a:ea typeface="Times New Roman"/>
               </a:rPr>
-              <a:t>Laâyoune, Boujdour, and Foum Eloued are recorded in Amperes, while Marrakech is recorded in Kilowatts. This will be a known limitation for a direct cross-city magnitude comparison unless we do a unit conversion per row.</a:t>
+              <a:t>Since Laâyoune, Boujdour, and Foum Eloued are metered in Amperes, converting to kW requires a voltage assumption (the    dataset doesn't include voltage directly, only the meter read, ie total consumption):</a:t>
             </a:r>
             <a:endParaRPr b="0" lang="en-US" sz="1800" spc="-1" strike="noStrike">
               <a:solidFill>
@@ -7027,18 +7054,129 @@
             </a:endParaRPr>
           </a:p>
           <a:p>
-            <a:pPr marL="228600" indent="-228600">
+            <a:pPr indent="0">
               <a:lnSpc>
                 <a:spcPct val="90000"/>
               </a:lnSpc>
               <a:spcBef>
                 <a:spcPts val="1001"/>
               </a:spcBef>
-              <a:buClr>
-                <a:srgbClr val="000000"/>
-              </a:buClr>
-              <a:buFont typeface="Symbol" charset="2"/>
-              <a:buChar char=""/>
+              <a:buNone/>
+            </a:pPr>
+            <a:endParaRPr b="0" lang="en-US" sz="1800" spc="-1" strike="noStrike">
+              <a:solidFill>
+                <a:srgbClr val="000000"/>
+              </a:solidFill>
+              <a:latin typeface="Arial"/>
+            </a:endParaRPr>
+          </a:p>
+          <a:p>
+            <a:pPr indent="0">
+              <a:lnSpc>
+                <a:spcPct val="90000"/>
+              </a:lnSpc>
+              <a:spcBef>
+                <a:spcPts val="1001"/>
+              </a:spcBef>
+              <a:buNone/>
+            </a:pPr>
+            <a:r>
+              <a:rPr b="0" lang="en-US" sz="1800" spc="-1" strike="noStrike">
+                <a:solidFill>
+                  <a:srgbClr val="000000"/>
+                </a:solidFill>
+                <a:latin typeface="Times New Roman"/>
+                <a:ea typeface="Times New Roman"/>
+              </a:rPr>
+              <a:t>Single-phase: kW = (V × I × PF) / 1000</a:t>
+            </a:r>
+            <a:endParaRPr b="0" lang="en-US" sz="1800" spc="-1" strike="noStrike">
+              <a:solidFill>
+                <a:srgbClr val="000000"/>
+              </a:solidFill>
+              <a:latin typeface="Arial"/>
+            </a:endParaRPr>
+          </a:p>
+          <a:p>
+            <a:pPr indent="0">
+              <a:lnSpc>
+                <a:spcPct val="90000"/>
+              </a:lnSpc>
+              <a:spcBef>
+                <a:spcPts val="1001"/>
+              </a:spcBef>
+              <a:buNone/>
+            </a:pPr>
+            <a:r>
+              <a:rPr b="0" lang="en-US" sz="1800" spc="-1" strike="noStrike">
+                <a:solidFill>
+                  <a:srgbClr val="000000"/>
+                </a:solidFill>
+                <a:latin typeface="Times New Roman"/>
+                <a:ea typeface="Times New Roman"/>
+              </a:rPr>
+              <a:t>Three-phase: kW = (√3 × V × I × PF) / 1000</a:t>
+            </a:r>
+            <a:endParaRPr b="0" lang="en-US" sz="1800" spc="-1" strike="noStrike">
+              <a:solidFill>
+                <a:srgbClr val="000000"/>
+              </a:solidFill>
+              <a:latin typeface="Arial"/>
+            </a:endParaRPr>
+          </a:p>
+          <a:p>
+            <a:pPr indent="0">
+              <a:lnSpc>
+                <a:spcPct val="90000"/>
+              </a:lnSpc>
+              <a:spcBef>
+                <a:spcPts val="1001"/>
+              </a:spcBef>
+              <a:buNone/>
+            </a:pPr>
+            <a:endParaRPr b="0" lang="en-US" sz="1800" spc="-1" strike="noStrike">
+              <a:solidFill>
+                <a:srgbClr val="000000"/>
+              </a:solidFill>
+              <a:latin typeface="Arial"/>
+            </a:endParaRPr>
+          </a:p>
+          <a:p>
+            <a:pPr indent="0">
+              <a:lnSpc>
+                <a:spcPct val="90000"/>
+              </a:lnSpc>
+              <a:spcBef>
+                <a:spcPts val="1001"/>
+              </a:spcBef>
+              <a:buNone/>
+            </a:pPr>
+            <a:r>
+              <a:rPr b="0" lang="en-US" sz="1800" spc="-1" strike="noStrike">
+                <a:solidFill>
+                  <a:srgbClr val="000000"/>
+                </a:solidFill>
+                <a:latin typeface="Times New Roman"/>
+                <a:ea typeface="Times New Roman"/>
+              </a:rPr>
+              <a:t>Morocco's standard domestic supply is 220V AC single-phase; industrial connections are commonly 380V AC three-phase. Since the dataset separates domestic and industrial profiles, we will apply the matching formula per zone type, and we will state our assumed voltage per zone explicitly as a limitation in our report.</a:t>
+            </a:r>
+            <a:endParaRPr b="0" lang="en-US" sz="1800" spc="-1" strike="noStrike">
+              <a:solidFill>
+                <a:srgbClr val="000000"/>
+              </a:solidFill>
+              <a:latin typeface="Arial"/>
+            </a:endParaRPr>
+          </a:p>
+          <a:p>
+            <a:pPr indent="0">
+              <a:lnSpc>
+                <a:spcPct val="90000"/>
+              </a:lnSpc>
+              <a:spcBef>
+                <a:spcPts val="1001"/>
+              </a:spcBef>
+              <a:buNone/>
             </a:pPr>
             <a:r>
               <a:rPr b="0" lang="en-US" sz="1800" spc="-1" strike="noStrike">
@@ -7122,7 +7260,7 @@
         <p:spPr>
           <a:xfrm>
             <a:off x="838080" y="365040"/>
-            <a:ext cx="10514880" cy="1324800"/>
+            <a:ext cx="10514520" cy="1324440"/>
           </a:xfrm>
           <a:prstGeom prst="rect">
             <a:avLst/>
@@ -7177,7 +7315,7 @@
         <p:spPr>
           <a:xfrm>
             <a:off x="838080" y="1825560"/>
-            <a:ext cx="10514880" cy="4350600"/>
+            <a:ext cx="10514520" cy="4350240"/>
           </a:xfrm>
           <a:prstGeom prst="rect">
             <a:avLst/>
@@ -7192,18 +7330,14 @@
             <a:noAutofit/>
           </a:bodyPr>
           <a:p>
-            <a:pPr marL="228600" indent="-228600">
+            <a:pPr indent="0">
               <a:lnSpc>
                 <a:spcPct val="90000"/>
               </a:lnSpc>
               <a:spcBef>
                 <a:spcPts val="1001"/>
               </a:spcBef>
-              <a:buClr>
-                <a:srgbClr val="000000"/>
-              </a:buClr>
-              <a:buFont typeface="Arial"/>
-              <a:buChar char="•"/>
+              <a:buNone/>
             </a:pPr>
             <a:r>
               <a:rPr b="0" lang="en-US" sz="1800" spc="-1" strike="noStrike">
@@ -7213,7 +7347,51 @@
                 <a:latin typeface="Times New Roman"/>
                 <a:ea typeface="Times New Roman"/>
               </a:rPr>
-              <a:t>&lt;select analytical technique, build models&gt;</a:t>
+              <a:t>Applied a 90th-percentile-per-zone threshold to convert continuous kW readings into binary Peak/Normal labels — a data-driven definition that avoids assuming a fixed kW cutoff across cities with very different scales (e.g., Laâyoune's 90th percentile is 145 kW vs. Marrakech's 1,635 kW)</a:t>
+            </a:r>
+            <a:endParaRPr b="0" lang="en-US" sz="1800" spc="-1" strike="noStrike">
+              <a:solidFill>
+                <a:srgbClr val="000000"/>
+              </a:solidFill>
+              <a:latin typeface="Arial"/>
+            </a:endParaRPr>
+          </a:p>
+          <a:p>
+            <a:pPr indent="0">
+              <a:lnSpc>
+                <a:spcPct val="90000"/>
+              </a:lnSpc>
+              <a:spcBef>
+                <a:spcPts val="1001"/>
+              </a:spcBef>
+              <a:buNone/>
+            </a:pPr>
+            <a:endParaRPr b="0" lang="en-US" sz="1800" spc="-1" strike="noStrike">
+              <a:solidFill>
+                <a:srgbClr val="000000"/>
+              </a:solidFill>
+              <a:latin typeface="Arial"/>
+            </a:endParaRPr>
+          </a:p>
+          <a:p>
+            <a:pPr indent="0">
+              <a:lnSpc>
+                <a:spcPct val="90000"/>
+              </a:lnSpc>
+              <a:spcBef>
+                <a:spcPts val="1001"/>
+              </a:spcBef>
+              <a:buNone/>
+            </a:pPr>
+            <a:r>
+              <a:rPr b="0" lang="en-US" sz="1800" spc="-1" strike="noStrike">
+                <a:solidFill>
+                  <a:srgbClr val="000000"/>
+                </a:solidFill>
+                <a:latin typeface="Times New Roman"/>
+                <a:ea typeface="Times New Roman"/>
+              </a:rPr>
+              <a:t>Used comparative visual EDA such as boxplots (distribution shape per zone), an hour-of-day heatmap (when peaks occur), a seasonal peak-rate heatmap (whether peaks cluster by time of year), and a zone-to-zone correlation matrix (whether zones move together) as the primary analytical techniques for this phase.</a:t>
             </a:r>
             <a:endParaRPr b="0" lang="en-US" sz="1800" spc="-1" strike="noStrike">
               <a:solidFill>
@@ -7287,7 +7465,7 @@
         <p:spPr>
           <a:xfrm>
             <a:off x="838080" y="365040"/>
-            <a:ext cx="10514880" cy="1324800"/>
+            <a:ext cx="10514520" cy="1324440"/>
           </a:xfrm>
           <a:prstGeom prst="rect">
             <a:avLst/>
@@ -7342,7 +7520,7 @@
         <p:spPr>
           <a:xfrm>
             <a:off x="838080" y="1825560"/>
-            <a:ext cx="10514880" cy="4350600"/>
+            <a:ext cx="10514520" cy="4350240"/>
           </a:xfrm>
           <a:prstGeom prst="rect">
             <a:avLst/>
@@ -7357,18 +7535,14 @@
             <a:noAutofit/>
           </a:bodyPr>
           <a:p>
-            <a:pPr marL="228600" indent="-228600">
+            <a:pPr indent="0">
               <a:lnSpc>
                 <a:spcPct val="90000"/>
               </a:lnSpc>
               <a:spcBef>
                 <a:spcPts val="1001"/>
               </a:spcBef>
-              <a:buClr>
-                <a:srgbClr val="000000"/>
-              </a:buClr>
-              <a:buFont typeface="Arial"/>
-              <a:buChar char="•"/>
+              <a:buNone/>
             </a:pPr>
             <a:r>
               <a:rPr b="0" lang="en-US" sz="1800" spc="-1" strike="noStrike">
@@ -7378,7 +7552,7 @@
                 <a:latin typeface="Times New Roman"/>
                 <a:ea typeface="Times New Roman"/>
               </a:rPr>
-              <a:t>&lt;communicate results&gt;</a:t>
+              <a:t>Marrakech's totals are far higher than the other three cities, but this likely reflects the fact the population of the cities are so vastly different. (See Figure 1)</a:t>
             </a:r>
             <a:endParaRPr b="0" lang="en-US" sz="1800" spc="-1" strike="noStrike">
               <a:solidFill>
@@ -7396,11 +7570,184 @@
                 <a:spcPts val="1001"/>
               </a:spcBef>
               <a:buNone/>
+            </a:pPr>
+            <a:r>
+              <a:rPr b="0" lang="en-US" sz="1800" spc="-1" strike="noStrike">
+                <a:solidFill>
+                  <a:srgbClr val="000000"/>
+                </a:solidFill>
+                <a:latin typeface="Times New Roman"/>
+                <a:ea typeface="Times New Roman"/>
+              </a:rPr>
+              <a:t>Laâyoune and Boujdour peak in the evening (6–11 PM), consistent with residential usage; Marrakech peaks during business hours (8 AM–6 PM) with near-zero activity from 11 PM–6 AM, consistent with commercial/institutional load rather than residential</a:t>
+            </a:r>
+            <a:endParaRPr b="0" lang="en-US" sz="1800" spc="-1" strike="noStrike">
+              <a:solidFill>
+                <a:srgbClr val="000000"/>
+              </a:solidFill>
+              <a:latin typeface="Arial"/>
+            </a:endParaRPr>
+          </a:p>
+          <a:p>
+            <a:pPr indent="0">
+              <a:lnSpc>
+                <a:spcPct val="90000"/>
+              </a:lnSpc>
+              <a:spcBef>
+                <a:spcPts val="1001"/>
+              </a:spcBef>
+              <a:buNone/>
+            </a:pPr>
+            <a:r>
+              <a:rPr b="0" lang="en-US" sz="1800" spc="-1" strike="noStrike">
+                <a:solidFill>
+                  <a:srgbClr val="000000"/>
+                </a:solidFill>
+                <a:latin typeface="Times New Roman"/>
+                <a:ea typeface="Times New Roman"/>
+              </a:rPr>
+              <a:t>Foum Eloued's zone 6 spikes to a 45.9% peak rate in summer (vs. ~2% the rest of the year); Marrakech's zone 1 also peaks in summer (25.8%), both plausibly cooling-driven, while most Laâyoune and other Foum Eloued zones instead peak in fall</a:t>
+            </a:r>
+            <a:endParaRPr b="0" lang="en-US" sz="1800" spc="-1" strike="noStrike">
+              <a:solidFill>
+                <a:srgbClr val="000000"/>
+              </a:solidFill>
+              <a:latin typeface="Arial"/>
+            </a:endParaRPr>
+          </a:p>
+          <a:p>
+            <a:pPr indent="0">
+              <a:lnSpc>
+                <a:spcPct val="90000"/>
+              </a:lnSpc>
+              <a:spcBef>
+                <a:spcPts val="1001"/>
+              </a:spcBef>
+              <a:buNone/>
+            </a:pPr>
+            <a:r>
+              <a:rPr b="0" lang="en-US" sz="1800" spc="-1" strike="noStrike">
+                <a:solidFill>
+                  <a:srgbClr val="000000"/>
+                </a:solidFill>
+                <a:latin typeface="Times New Roman"/>
+                <a:ea typeface="Times New Roman"/>
+              </a:rPr>
+              <a:t>Laâyoune's zones 2–5 correlate at 0.71–0.88 with each other, and Foum Eloued's zones 1–4 similarly cluster (0.72–0.86), while cross-city correlations stay mostly under 0.3, this supports the idea that each region behaves independently</a:t>
+            </a:r>
+            <a:endParaRPr b="0" lang="en-US" sz="1800" spc="-1" strike="noStrike">
+              <a:solidFill>
+                <a:srgbClr val="000000"/>
+              </a:solidFill>
+              <a:latin typeface="Arial"/>
+            </a:endParaRPr>
+          </a:p>
+          <a:p>
+            <a:pPr indent="0">
+              <a:lnSpc>
+                <a:spcPct val="90000"/>
+              </a:lnSpc>
+              <a:spcBef>
+                <a:spcPts val="1001"/>
+              </a:spcBef>
+              <a:buNone/>
+            </a:pPr>
+            <a:r>
+              <a:rPr b="0" lang="en-US" sz="1800" spc="-1" strike="noStrike">
+                <a:solidFill>
+                  <a:srgbClr val="000000"/>
+                </a:solidFill>
+                <a:latin typeface="Times New Roman"/>
+                <a:ea typeface="Times New Roman"/>
+              </a:rPr>
+              <a:t>Peak timing and seasonal patterns clearly vary by region, supporting the hypothesis statement; direct intensity comparisons across cities remain confounded by unit/aggregation differences and are noted as a limitation for future work</a:t>
+            </a:r>
+            <a:endParaRPr b="0" lang="en-US" sz="1800" spc="-1" strike="noStrike">
+              <a:solidFill>
+                <a:srgbClr val="000000"/>
+              </a:solidFill>
+              <a:latin typeface="Arial"/>
+            </a:endParaRPr>
+          </a:p>
+          <a:p>
+            <a:pPr indent="0">
+              <a:lnSpc>
+                <a:spcPct val="90000"/>
+              </a:lnSpc>
+              <a:spcBef>
+                <a:spcPts val="1001"/>
+              </a:spcBef>
+              <a:buNone/>
               <a:tabLst>
                 <a:tab algn="l" pos="0"/>
               </a:tabLst>
             </a:pPr>
             <a:endParaRPr b="0" lang="en-US" sz="2800" spc="-1" strike="noStrike">
+              <a:solidFill>
+                <a:srgbClr val="000000"/>
+              </a:solidFill>
+              <a:latin typeface="Arial"/>
+            </a:endParaRPr>
+          </a:p>
+        </p:txBody>
+      </p:sp>
+      <p:pic>
+        <p:nvPicPr>
+          <p:cNvPr id="96" name="" descr=""/>
+          <p:cNvPicPr/>
+          <p:nvPr/>
+        </p:nvPicPr>
+        <p:blipFill>
+          <a:blip r:embed="rId1"/>
+          <a:stretch/>
+        </p:blipFill>
+        <p:spPr>
+          <a:xfrm>
+            <a:off x="7652160" y="0"/>
+            <a:ext cx="4539960" cy="1510920"/>
+          </a:xfrm>
+          <a:prstGeom prst="rect">
+            <a:avLst/>
+          </a:prstGeom>
+          <a:ln w="0">
+            <a:noFill/>
+          </a:ln>
+        </p:spPr>
+      </p:pic>
+      <p:sp>
+        <p:nvSpPr>
+          <p:cNvPr id="97" name=""/>
+          <p:cNvSpPr txBox="1"/>
+          <p:nvPr/>
+        </p:nvSpPr>
+        <p:spPr>
+          <a:xfrm>
+            <a:off x="6755040" y="18720"/>
+            <a:ext cx="1017360" cy="346320"/>
+          </a:xfrm>
+          <a:prstGeom prst="rect">
+            <a:avLst/>
+          </a:prstGeom>
+          <a:noFill/>
+          <a:ln w="0">
+            <a:noFill/>
+          </a:ln>
+        </p:spPr>
+        <p:txBody>
+          <a:bodyPr lIns="90000" rIns="90000" tIns="45000" bIns="45000" anchor="t">
+            <a:noAutofit/>
+          </a:bodyPr>
+          <a:p>
+            <a:r>
+              <a:rPr b="0" i="1" lang="en-US" sz="1800" spc="-1" strike="noStrike">
+                <a:solidFill>
+                  <a:srgbClr val="000000"/>
+                </a:solidFill>
+                <a:latin typeface="Arial"/>
+              </a:rPr>
+              <a:t>Figure 1</a:t>
+            </a:r>
+            <a:endParaRPr b="0" lang="en-US" sz="1800" spc="-1" strike="noStrike">
               <a:solidFill>
                 <a:srgbClr val="000000"/>
               </a:solidFill>
@@ -7441,7 +7788,7 @@
       </p:grpSpPr>
       <p:sp>
         <p:nvSpPr>
-          <p:cNvPr id="96" name="PlaceHolder 1"/>
+          <p:cNvPr id="98" name="PlaceHolder 1"/>
           <p:cNvSpPr>
             <a:spLocks noGrp="1"/>
           </p:cNvSpPr>
@@ -7452,7 +7799,7 @@
         <p:spPr>
           <a:xfrm>
             <a:off x="838080" y="365040"/>
-            <a:ext cx="10514880" cy="1324800"/>
+            <a:ext cx="10514520" cy="1324440"/>
           </a:xfrm>
           <a:prstGeom prst="rect">
             <a:avLst/>
@@ -7496,7 +7843,7 @@
       </p:sp>
       <p:sp>
         <p:nvSpPr>
-          <p:cNvPr id="97" name="PlaceHolder 2"/>
+          <p:cNvPr id="99" name="PlaceHolder 2"/>
           <p:cNvSpPr>
             <a:spLocks noGrp="1"/>
           </p:cNvSpPr>
@@ -7507,7 +7854,7 @@
         <p:spPr>
           <a:xfrm>
             <a:off x="838080" y="1825560"/>
-            <a:ext cx="10514880" cy="4350600"/>
+            <a:ext cx="10514520" cy="4350240"/>
           </a:xfrm>
           <a:prstGeom prst="rect">
             <a:avLst/>
@@ -7522,18 +7869,14 @@
             <a:noAutofit/>
           </a:bodyPr>
           <a:p>
-            <a:pPr marL="228600" indent="-228600">
+            <a:pPr indent="0">
               <a:lnSpc>
                 <a:spcPct val="90000"/>
               </a:lnSpc>
               <a:spcBef>
                 <a:spcPts val="1001"/>
               </a:spcBef>
-              <a:buClr>
-                <a:srgbClr val="000000"/>
-              </a:buClr>
-              <a:buFont typeface="Arial"/>
-              <a:buChar char="•"/>
+              <a:buNone/>
             </a:pPr>
             <a:r>
               <a:rPr b="0" lang="en-US" sz="1800" spc="-1" strike="noStrike">
@@ -7543,7 +7886,7 @@
                 <a:latin typeface="Times New Roman"/>
                 <a:ea typeface="Times New Roman"/>
               </a:rPr>
-              <a:t>&lt;apply results, connect results with the chosen problem statement or business question&gt;</a:t>
+              <a:t>Micro-Project 3 will apply linear regression as a baseline model and Support Vector Regression (SVM) regression to predict continuous load values from time-based features (hour, season, zone). I may also apply an autoregressive integrated moving average (ARIMA) as that is also a popular choice for analyzing and forecasting time series data to compare to the SVM regression. Micro-Project 4 will apply RNN-based deep learning to model the sequential/time-series structure directly</a:t>
             </a:r>
             <a:endParaRPr b="0" lang="en-US" sz="1800" spc="-1" strike="noStrike">
               <a:solidFill>

</xml_diff>